<commit_message>
Poster updated & added all used resources
</commit_message>
<xml_diff>
--- a/Poster/Poster.pptx
+++ b/Poster/Poster.pptx
@@ -1992,7 +1992,7 @@
         <p:spPr>
           <a:xfrm>
             <a:off x="678097" y="16727750"/>
-            <a:ext cx="12865940" cy="1275469"/>
+            <a:ext cx="12865940" cy="1044188"/>
           </a:xfrm>
           <a:ln>
             <a:solidFill>
@@ -2006,12 +2006,9 @@
           <a:p>
             <a:pPr lvl="1" algn="just"/>
             <a:r>
-              <a:rPr lang="nl-BE" noProof="0" dirty="0"/>
-              <a:t>tekst</a:t>
-            </a:r>
-          </a:p>
-          <a:p>
-            <a:pPr lvl="1"/>
+              <a:rPr lang="nl-BE" dirty="0"/>
+              <a:t>Het voordeel van deze oplossing is dat er nu een </a:t>
+            </a:r>
             <a:endParaRPr lang="nl-BE" noProof="0" dirty="0"/>
           </a:p>
           <a:p>
@@ -2668,42 +2665,6 @@
       </p:sp>
       <p:pic>
         <p:nvPicPr>
-          <p:cNvPr id="23" name="Picture 22">
-            <a:extLst>
-              <a:ext uri="{FF2B5EF4-FFF2-40B4-BE49-F238E27FC236}">
-                <a16:creationId xmlns:a16="http://schemas.microsoft.com/office/drawing/2014/main" id="{1899F172-C6B7-646F-0329-5857B50F5E37}"/>
-              </a:ext>
-            </a:extLst>
-          </p:cNvPr>
-          <p:cNvPicPr>
-            <a:picLocks noChangeAspect="1"/>
-          </p:cNvPicPr>
-          <p:nvPr/>
-        </p:nvPicPr>
-        <p:blipFill>
-          <a:blip r:embed="rId4">
-            <a:extLst>
-              <a:ext uri="{28A0092B-C50C-407E-A947-70E740481C1C}">
-                <a14:useLocalDpi xmlns:a14="http://schemas.microsoft.com/office/drawing/2010/main" val="0"/>
-              </a:ext>
-            </a:extLst>
-          </a:blip>
-          <a:stretch>
-            <a:fillRect/>
-          </a:stretch>
-        </p:blipFill>
-        <p:spPr>
-          <a:xfrm>
-            <a:off x="676438" y="7230262"/>
-            <a:ext cx="8081224" cy="5765817"/>
-          </a:xfrm>
-          <a:prstGeom prst="rect">
-            <a:avLst/>
-          </a:prstGeom>
-        </p:spPr>
-      </p:pic>
-      <p:pic>
-        <p:nvPicPr>
           <p:cNvPr id="25" name="Picture 24">
             <a:extLst>
               <a:ext uri="{FF2B5EF4-FFF2-40B4-BE49-F238E27FC236}">
@@ -2717,7 +2678,7 @@
           <p:nvPr/>
         </p:nvPicPr>
         <p:blipFill>
-          <a:blip r:embed="rId5">
+          <a:blip r:embed="rId4">
             <a:extLst>
               <a:ext uri="{28A0092B-C50C-407E-A947-70E740481C1C}">
                 <a14:useLocalDpi xmlns:a14="http://schemas.microsoft.com/office/drawing/2010/main" val="0"/>
@@ -3130,7 +3091,7 @@
             </a:lvl9pPr>
           </a:lstStyle>
           <a:p>
-            <a:pPr lvl="1"/>
+            <a:pPr lvl="1" algn="just"/>
             <a:r>
               <a:rPr lang="nl-BE" dirty="0"/>
               <a:t>Is een netwerkemulatiesoftware dat het mogelijk maakt om </a:t>
@@ -3146,42 +3107,6 @@
           </a:p>
         </p:txBody>
       </p:sp>
-      <p:pic>
-        <p:nvPicPr>
-          <p:cNvPr id="12" name="Picture 11">
-            <a:extLst>
-              <a:ext uri="{FF2B5EF4-FFF2-40B4-BE49-F238E27FC236}">
-                <a16:creationId xmlns:a16="http://schemas.microsoft.com/office/drawing/2014/main" id="{17894FF3-3F74-15C2-36ED-224D772E10D1}"/>
-              </a:ext>
-            </a:extLst>
-          </p:cNvPr>
-          <p:cNvPicPr>
-            <a:picLocks noChangeAspect="1"/>
-          </p:cNvPicPr>
-          <p:nvPr/>
-        </p:nvPicPr>
-        <p:blipFill>
-          <a:blip r:embed="rId6">
-            <a:extLst>
-              <a:ext uri="{28A0092B-C50C-407E-A947-70E740481C1C}">
-                <a14:useLocalDpi xmlns:a14="http://schemas.microsoft.com/office/drawing/2010/main" val="0"/>
-              </a:ext>
-            </a:extLst>
-          </a:blip>
-          <a:stretch>
-            <a:fillRect/>
-          </a:stretch>
-        </p:blipFill>
-        <p:spPr>
-          <a:xfrm>
-            <a:off x="6295509" y="14211743"/>
-            <a:ext cx="7248525" cy="962025"/>
-          </a:xfrm>
-          <a:prstGeom prst="rect">
-            <a:avLst/>
-          </a:prstGeom>
-        </p:spPr>
-      </p:pic>
       <p:sp>
         <p:nvSpPr>
           <p:cNvPr id="13" name="Text Placeholder 10">
@@ -3574,7 +3499,7 @@
             </a:lvl9pPr>
           </a:lstStyle>
           <a:p>
-            <a:pPr lvl="1"/>
+            <a:pPr lvl="1" algn="just"/>
             <a:r>
               <a:rPr lang="nl-BE" dirty="0"/>
               <a:t>De verschillende labo’s kunnen aan de hand van een Python script volledig van begin af aan worden aangemaakt op de EVE-NG server.</a:t>
@@ -3582,6 +3507,78 @@
           </a:p>
         </p:txBody>
       </p:sp>
+      <p:pic>
+        <p:nvPicPr>
+          <p:cNvPr id="17" name="Picture 16">
+            <a:extLst>
+              <a:ext uri="{FF2B5EF4-FFF2-40B4-BE49-F238E27FC236}">
+                <a16:creationId xmlns:a16="http://schemas.microsoft.com/office/drawing/2014/main" id="{8397D068-8406-1BC7-76A8-2A3BE224A29E}"/>
+              </a:ext>
+            </a:extLst>
+          </p:cNvPr>
+          <p:cNvPicPr>
+            <a:picLocks noChangeAspect="1"/>
+          </p:cNvPicPr>
+          <p:nvPr/>
+        </p:nvPicPr>
+        <p:blipFill>
+          <a:blip r:embed="rId5">
+            <a:extLst>
+              <a:ext uri="{28A0092B-C50C-407E-A947-70E740481C1C}">
+                <a14:useLocalDpi xmlns:a14="http://schemas.microsoft.com/office/drawing/2010/main" val="0"/>
+              </a:ext>
+            </a:extLst>
+          </a:blip>
+          <a:stretch>
+            <a:fillRect/>
+          </a:stretch>
+        </p:blipFill>
+        <p:spPr>
+          <a:xfrm>
+            <a:off x="6486009" y="14600147"/>
+            <a:ext cx="7058025" cy="1057275"/>
+          </a:xfrm>
+          <a:prstGeom prst="rect">
+            <a:avLst/>
+          </a:prstGeom>
+        </p:spPr>
+      </p:pic>
+      <p:pic>
+        <p:nvPicPr>
+          <p:cNvPr id="21" name="Picture 20">
+            <a:extLst>
+              <a:ext uri="{FF2B5EF4-FFF2-40B4-BE49-F238E27FC236}">
+                <a16:creationId xmlns:a16="http://schemas.microsoft.com/office/drawing/2014/main" id="{FB2482D3-652B-2BD8-BE5A-06F2A12B4C3A}"/>
+              </a:ext>
+            </a:extLst>
+          </p:cNvPr>
+          <p:cNvPicPr>
+            <a:picLocks noChangeAspect="1"/>
+          </p:cNvPicPr>
+          <p:nvPr/>
+        </p:nvPicPr>
+        <p:blipFill>
+          <a:blip r:embed="rId6">
+            <a:extLst>
+              <a:ext uri="{28A0092B-C50C-407E-A947-70E740481C1C}">
+                <a14:useLocalDpi xmlns:a14="http://schemas.microsoft.com/office/drawing/2010/main" val="0"/>
+              </a:ext>
+            </a:extLst>
+          </a:blip>
+          <a:stretch>
+            <a:fillRect/>
+          </a:stretch>
+        </p:blipFill>
+        <p:spPr>
+          <a:xfrm>
+            <a:off x="676438" y="7085161"/>
+            <a:ext cx="8616220" cy="6147528"/>
+          </a:xfrm>
+          <a:prstGeom prst="rect">
+            <a:avLst/>
+          </a:prstGeom>
+        </p:spPr>
+      </p:pic>
     </p:spTree>
     <p:extLst>
       <p:ext uri="{BB962C8B-B14F-4D97-AF65-F5344CB8AC3E}">

</xml_diff>

<commit_message>
fixed minor spelling mistake
</commit_message>
<xml_diff>
--- a/Poster/Poster.pptx
+++ b/Poster/Poster.pptx
@@ -3087,7 +3087,7 @@
             </a:lvl9pPr>
           </a:lstStyle>
           <a:p>
-            <a:pPr lvl="1" algn="just"/>
+            <a:pPr lvl="1"/>
             <a:r>
               <a:rPr lang="nl-BE" dirty="0"/>
               <a:t>Is een netwerkemulatiesoftware dat het mogelijk maakt om netwerktopologieën te ontwerpen en te testen in een virtuele omgeving. EVE-NG draait netwerktoestellen als virtuele machines op een server</a:t>
@@ -3490,7 +3490,7 @@
             <a:pPr lvl="1" algn="just"/>
             <a:r>
               <a:rPr lang="nl-BE" dirty="0"/>
-              <a:t>De verschillende labo’s kunnen aan de hand van een Python script van begin af aan worden aangemaakt op de EVE-NG server.</a:t>
+              <a:t>De verschillende labo’s kunnen aan de hand van een Python script volledig worden aangemaakt op de EVE-NG server.</a:t>
             </a:r>
           </a:p>
         </p:txBody>
@@ -3908,15 +3908,6 @@
 </file>
 
 <file path=customXml/item2.xml><?xml version="1.0" encoding="utf-8"?>
-<?mso-contentType ?>
-<FormTemplates xmlns="http://schemas.microsoft.com/sharepoint/v3/contenttype/forms">
-  <Display>DocumentLibraryForm</Display>
-  <Edit>DocumentLibraryForm</Edit>
-  <New>DocumentLibraryForm</New>
-</FormTemplates>
-</file>
-
-<file path=customXml/item3.xml><?xml version="1.0" encoding="utf-8"?>
 <ct:contentTypeSchema xmlns:ct="http://schemas.microsoft.com/office/2006/metadata/contentType" xmlns:ma="http://schemas.microsoft.com/office/2006/metadata/properties/metaAttributes" ct:_="" ma:_="" ma:contentTypeName="Document" ma:contentTypeID="0x0101001A307FBA45E73B4C8D5201D6E93AE7FF" ma:contentTypeVersion="10" ma:contentTypeDescription="Een nieuw document maken." ma:contentTypeScope="" ma:versionID="ffc79c833aa11187a9b03609d0ef013b">
   <xsd:schema xmlns:xsd="http://www.w3.org/2001/XMLSchema" xmlns:xs="http://www.w3.org/2001/XMLSchema" xmlns:p="http://schemas.microsoft.com/office/2006/metadata/properties" xmlns:ns2="08656f9a-5533-445c-9745-8b78b9f32e94" targetNamespace="http://schemas.microsoft.com/office/2006/metadata/properties" ma:root="true" ma:fieldsID="f1de88abeb94c0a233512af3206a5add" ns2:_="">
     <xsd:import namespace="08656f9a-5533-445c-9745-8b78b9f32e94"/>
@@ -4098,6 +4089,15 @@
 </ct:contentTypeSchema>
 </file>
 
+<file path=customXml/item3.xml><?xml version="1.0" encoding="utf-8"?>
+<?mso-contentType ?>
+<FormTemplates xmlns="http://schemas.microsoft.com/sharepoint/v3/contenttype/forms">
+  <Display>DocumentLibraryForm</Display>
+  <Edit>DocumentLibraryForm</Edit>
+  <New>DocumentLibraryForm</New>
+</FormTemplates>
+</file>
+
 <file path=customXml/itemProps1.xml><?xml version="1.0" encoding="utf-8"?>
 <ds:datastoreItem xmlns:ds="http://schemas.openxmlformats.org/officeDocument/2006/customXml" ds:itemID="{2DE7141F-FBCE-4A78-9588-4D54994EB7FA}">
   <ds:schemaRefs>
@@ -4115,14 +4115,6 @@
 </file>
 
 <file path=customXml/itemProps2.xml><?xml version="1.0" encoding="utf-8"?>
-<ds:datastoreItem xmlns:ds="http://schemas.openxmlformats.org/officeDocument/2006/customXml" ds:itemID="{DB4C8F74-1D82-4571-8BB4-C4A1A1557DE1}">
-  <ds:schemaRefs>
-    <ds:schemaRef ds:uri="http://schemas.microsoft.com/sharepoint/v3/contenttype/forms"/>
-  </ds:schemaRefs>
-</ds:datastoreItem>
-</file>
-
-<file path=customXml/itemProps3.xml><?xml version="1.0" encoding="utf-8"?>
 <ds:datastoreItem xmlns:ds="http://schemas.openxmlformats.org/officeDocument/2006/customXml" ds:itemID="{0677BFE8-9222-4836-8D51-287619E2A1F6}">
   <ds:schemaRefs>
     <ds:schemaRef ds:uri="http://schemas.microsoft.com/office/2006/metadata/contentType"/>
@@ -4138,4 +4130,12 @@
     <ds:schemaRef ds:uri="http://schemas.microsoft.com/internal/obd"/>
   </ds:schemaRefs>
 </ds:datastoreItem>
+</file>
+
+<file path=customXml/itemProps3.xml><?xml version="1.0" encoding="utf-8"?>
+<ds:datastoreItem xmlns:ds="http://schemas.openxmlformats.org/officeDocument/2006/customXml" ds:itemID="{DB4C8F74-1D82-4571-8BB4-C4A1A1557DE1}">
+  <ds:schemaRefs>
+    <ds:schemaRef ds:uri="http://schemas.microsoft.com/sharepoint/v3/contenttype/forms"/>
+  </ds:schemaRefs>
+</ds:datastoreItem>
 </file>
</xml_diff>